<commit_message>
Modalidad virtual sincrona en los 4 cursos y material regenerado desde la fuente
</commit_message>
<xml_diff>
--- a/Programacion II/Clases/Clase 1 - Introduccion a POO/Presentacion.pptx
+++ b/Programacion II/Clases/Clase 1 - Introduccion a POO/Presentacion.pptx
@@ -8435,7 +8435,7 @@
         <p:spPr>
           <a:xfrm>
             <a:off x="457200" y="1234440"/>
-            <a:ext cx="11277295" cy="777240"/>
+            <a:ext cx="11277295" cy="950976"/>
           </a:xfrm>
           <a:prstGeom prst="roundRect">
             <a:avLst>
@@ -8479,7 +8479,7 @@
         </p:nvSpPr>
         <p:spPr>
           <a:xfrm>
-            <a:off x="594360" y="1403604"/>
+            <a:off x="594360" y="1490472"/>
             <a:ext cx="438912" cy="438912"/>
           </a:xfrm>
           <a:prstGeom prst="roundRect">
@@ -8524,7 +8524,7 @@
         </p:nvSpPr>
         <p:spPr>
           <a:xfrm>
-            <a:off x="594360" y="1403604"/>
+            <a:off x="594360" y="1490472"/>
             <a:ext cx="438912" cy="438912"/>
           </a:xfrm>
           <a:prstGeom prst="rect">
@@ -8558,7 +8558,7 @@
         <p:spPr>
           <a:xfrm>
             <a:off x="1188720" y="1325880"/>
-            <a:ext cx="10271455" cy="612647"/>
+            <a:ext cx="10271455" cy="786384"/>
           </a:xfrm>
           <a:prstGeom prst="rect">
             <a:avLst/>
@@ -8589,8 +8589,8 @@
         </p:nvSpPr>
         <p:spPr>
           <a:xfrm>
-            <a:off x="457200" y="2103120"/>
-            <a:ext cx="11277295" cy="777240"/>
+            <a:off x="457200" y="2276856"/>
+            <a:ext cx="11277295" cy="950976"/>
           </a:xfrm>
           <a:prstGeom prst="roundRect">
             <a:avLst>
@@ -8634,7 +8634,7 @@
         </p:nvSpPr>
         <p:spPr>
           <a:xfrm>
-            <a:off x="594360" y="2272284"/>
+            <a:off x="594360" y="2532888"/>
             <a:ext cx="438912" cy="438912"/>
           </a:xfrm>
           <a:prstGeom prst="roundRect">
@@ -8679,7 +8679,7 @@
         </p:nvSpPr>
         <p:spPr>
           <a:xfrm>
-            <a:off x="594360" y="2272284"/>
+            <a:off x="594360" y="2532888"/>
             <a:ext cx="438912" cy="438912"/>
           </a:xfrm>
           <a:prstGeom prst="rect">
@@ -8712,8 +8712,8 @@
         </p:nvSpPr>
         <p:spPr>
           <a:xfrm>
-            <a:off x="1188720" y="2194560"/>
-            <a:ext cx="10271455" cy="612647"/>
+            <a:off x="1188720" y="2368296"/>
+            <a:ext cx="10271455" cy="786384"/>
           </a:xfrm>
           <a:prstGeom prst="rect">
             <a:avLst/>
@@ -8744,8 +8744,8 @@
         </p:nvSpPr>
         <p:spPr>
           <a:xfrm>
-            <a:off x="457200" y="2971800"/>
-            <a:ext cx="11277295" cy="777240"/>
+            <a:off x="457200" y="3319272"/>
+            <a:ext cx="11277295" cy="950976"/>
           </a:xfrm>
           <a:prstGeom prst="roundRect">
             <a:avLst>
@@ -8789,7 +8789,7 @@
         </p:nvSpPr>
         <p:spPr>
           <a:xfrm>
-            <a:off x="594360" y="3140964"/>
+            <a:off x="594360" y="3575304"/>
             <a:ext cx="438912" cy="438912"/>
           </a:xfrm>
           <a:prstGeom prst="roundRect">
@@ -8834,7 +8834,7 @@
         </p:nvSpPr>
         <p:spPr>
           <a:xfrm>
-            <a:off x="594360" y="3140964"/>
+            <a:off x="594360" y="3575304"/>
             <a:ext cx="438912" cy="438912"/>
           </a:xfrm>
           <a:prstGeom prst="rect">
@@ -8867,8 +8867,8 @@
         </p:nvSpPr>
         <p:spPr>
           <a:xfrm>
-            <a:off x="1188720" y="3063240"/>
-            <a:ext cx="10271455" cy="612647"/>
+            <a:off x="1188720" y="3410712"/>
+            <a:ext cx="10271455" cy="786384"/>
           </a:xfrm>
           <a:prstGeom prst="rect">
             <a:avLst/>
@@ -8899,8 +8899,8 @@
         </p:nvSpPr>
         <p:spPr>
           <a:xfrm>
-            <a:off x="457200" y="3840479"/>
-            <a:ext cx="11277295" cy="777240"/>
+            <a:off x="457200" y="4361688"/>
+            <a:ext cx="11277295" cy="950976"/>
           </a:xfrm>
           <a:prstGeom prst="roundRect">
             <a:avLst>
@@ -8944,7 +8944,7 @@
         </p:nvSpPr>
         <p:spPr>
           <a:xfrm>
-            <a:off x="594360" y="4009643"/>
+            <a:off x="594360" y="4617720"/>
             <a:ext cx="438912" cy="438912"/>
           </a:xfrm>
           <a:prstGeom prst="roundRect">
@@ -8989,7 +8989,7 @@
         </p:nvSpPr>
         <p:spPr>
           <a:xfrm>
-            <a:off x="594360" y="4009643"/>
+            <a:off x="594360" y="4617720"/>
             <a:ext cx="438912" cy="438912"/>
           </a:xfrm>
           <a:prstGeom prst="rect">
@@ -9022,8 +9022,8 @@
         </p:nvSpPr>
         <p:spPr>
           <a:xfrm>
-            <a:off x="1188720" y="3931919"/>
-            <a:ext cx="10271455" cy="612647"/>
+            <a:off x="1188720" y="4453128"/>
+            <a:ext cx="10271455" cy="786384"/>
           </a:xfrm>
           <a:prstGeom prst="rect">
             <a:avLst/>
@@ -9054,8 +9054,8 @@
         </p:nvSpPr>
         <p:spPr>
           <a:xfrm>
-            <a:off x="457200" y="4709160"/>
-            <a:ext cx="11277295" cy="777240"/>
+            <a:off x="457200" y="5404104"/>
+            <a:ext cx="11277295" cy="950976"/>
           </a:xfrm>
           <a:prstGeom prst="roundRect">
             <a:avLst>
@@ -9099,7 +9099,7 @@
         </p:nvSpPr>
         <p:spPr>
           <a:xfrm>
-            <a:off x="594360" y="4878324"/>
+            <a:off x="594360" y="5660136"/>
             <a:ext cx="438912" cy="438912"/>
           </a:xfrm>
           <a:prstGeom prst="roundRect">
@@ -9144,7 +9144,7 @@
         </p:nvSpPr>
         <p:spPr>
           <a:xfrm>
-            <a:off x="594360" y="4878324"/>
+            <a:off x="594360" y="5660136"/>
             <a:ext cx="438912" cy="438912"/>
           </a:xfrm>
           <a:prstGeom prst="rect">
@@ -9177,8 +9177,8 @@
         </p:nvSpPr>
         <p:spPr>
           <a:xfrm>
-            <a:off x="1188720" y="4800600"/>
-            <a:ext cx="10271455" cy="612647"/>
+            <a:off x="1188720" y="5495544"/>
+            <a:ext cx="10271455" cy="786384"/>
           </a:xfrm>
           <a:prstGeom prst="rect">
             <a:avLst/>

</xml_diff>